<commit_message>
fix(layout): 06-hooks 多張投影片底部重疊 + 00-overview Slide 23 箭頭
06-hooks 修了以下投影片（總計約 19 張）：
- Slide 6 (Hook 解析流程): 流程圖 step_h 0.8→0.7、整體往上挪
- Slide 9 (Matcher 模式): 標題往上、表格 3.0→2.5
- Slide 13 (Command Hook): code 高度加大、文字下移
- Slide 17 (退出碼語意): code 高度 2.0→2.5、文字重排
- Slide 18 (JSON 決策控制): code 高度加大
- Slide 19 (決策優先級): 方塊高度 2.0→1.7
- Slide 22 (PostToolUse): 左右 code 框加大
- Slide 23 (Stop Hook): code 框高度加大
- Slide 24 (SessionStart): 兩個 code 框加大、整體重排
- Slide 25 (Notification): code 高度 2.0→2.4
- Slide 26 (背景執行): code 高度 2.0→2.5
- Slide 30 (安全性): 整體往上移 0.5"、兩欄加高
- Slide 31 (除錯技巧): 標題往下、bullet 往上、整體重排
- Slide 32 (PowerShell): 兩個 code 框加大、字體縮小
- Slide 33 (常見模式): code 字體 8→10pt
- Slide 35 (編輯後跑測試): 右側 async 註解整合進 code block
- Slide 36 (Hooks 在 Skill/Subagent): code 精簡、字體 8→9pt、兩欄加高

00-overview Slide 23 (實戰組合應用):
- 兩個 connector 線改用 RIGHT_ARROW 三角形，避免穿過 Plugin 中央
- 黑箭頭 (CLAUDE.md → Plugin)
- 綠箭頭 (Plugin → Marketplace)
</commit_message>
<xml_diff>
--- a/00-overview.pptx
+++ b/00-overview.pptx
@@ -15567,41 +15567,49 @@
           </a:p>
         </p:txBody>
       </p:sp>
-      <p:cxnSp>
-        <p:nvCxnSpPr>
-          <p:cNvPr id="25" name="Connector 24"/>
-          <p:cNvCxnSpPr/>
-          <p:nvPr/>
-        </p:nvCxnSpPr>
-        <p:spPr>
-          <a:xfrm flipH="1" flipV="1">
-            <a:off x="640080" y="0"/>
-            <a:ext cx="7863840" cy="3200400"/>
-          </a:xfrm>
-          <a:prstGeom prst="line">
-            <a:avLst/>
-          </a:prstGeom>
-          <a:ln w="25400">
-            <a:solidFill>
-              <a:srgbClr val="0E7C66"/>
-            </a:solidFill>
+      <p:sp>
+        <p:nvSpPr>
+          <p:cNvPr id="25" name="Right Arrow 24"/>
+          <p:cNvSpPr/>
+          <p:nvPr/>
+        </p:nvSpPr>
+        <p:spPr>
+          <a:xfrm>
+            <a:off x="8503920" y="3063240"/>
+            <a:ext cx="640080" cy="274320"/>
+          </a:xfrm>
+          <a:prstGeom prst="rightArrow">
+            <a:avLst/>
+          </a:prstGeom>
+          <a:solidFill>
+            <a:srgbClr val="0E7C66"/>
+          </a:solidFill>
+          <a:ln>
+            <a:noFill/>
           </a:ln>
         </p:spPr>
         <p:style>
-          <a:lnRef idx="2">
+          <a:lnRef idx="1">
             <a:schemeClr val="accent1"/>
           </a:lnRef>
-          <a:fillRef idx="0">
+          <a:fillRef idx="3">
             <a:schemeClr val="accent1"/>
           </a:fillRef>
-          <a:effectRef idx="1">
+          <a:effectRef idx="2">
             <a:schemeClr val="accent1"/>
           </a:effectRef>
           <a:fontRef idx="minor">
-            <a:schemeClr val="tx1"/>
+            <a:schemeClr val="lt1"/>
           </a:fontRef>
         </p:style>
-      </p:cxnSp>
+        <p:txBody>
+          <a:bodyPr rtlCol="0" anchor="ctr"/>
+          <a:lstStyle/>
+          <a:p>
+            <a:pPr algn="ctr"/>
+          </a:p>
+        </p:txBody>
+      </p:sp>
       <p:sp>
         <p:nvSpPr>
           <p:cNvPr id="26" name="Rounded Rectangle 25"/>
@@ -15718,41 +15726,49 @@
           </a:p>
         </p:txBody>
       </p:sp>
-      <p:cxnSp>
-        <p:nvCxnSpPr>
-          <p:cNvPr id="29" name="Connector 28"/>
-          <p:cNvCxnSpPr/>
-          <p:nvPr/>
-        </p:nvCxnSpPr>
-        <p:spPr>
-          <a:xfrm flipH="1" flipV="1">
-            <a:off x="457200" y="0"/>
-            <a:ext cx="2743200" cy="3200400"/>
-          </a:xfrm>
-          <a:prstGeom prst="line">
-            <a:avLst/>
-          </a:prstGeom>
-          <a:ln w="25400">
-            <a:solidFill>
-              <a:srgbClr val="2C2C2C"/>
-            </a:solidFill>
+      <p:sp>
+        <p:nvSpPr>
+          <p:cNvPr id="29" name="Right Arrow 28"/>
+          <p:cNvSpPr/>
+          <p:nvPr/>
+        </p:nvSpPr>
+        <p:spPr>
+          <a:xfrm>
+            <a:off x="3200400" y="3063240"/>
+            <a:ext cx="457200" cy="274320"/>
+          </a:xfrm>
+          <a:prstGeom prst="rightArrow">
+            <a:avLst/>
+          </a:prstGeom>
+          <a:solidFill>
+            <a:srgbClr val="2C2C2C"/>
+          </a:solidFill>
+          <a:ln>
+            <a:noFill/>
           </a:ln>
         </p:spPr>
         <p:style>
-          <a:lnRef idx="2">
+          <a:lnRef idx="1">
             <a:schemeClr val="accent1"/>
           </a:lnRef>
-          <a:fillRef idx="0">
+          <a:fillRef idx="3">
             <a:schemeClr val="accent1"/>
           </a:fillRef>
-          <a:effectRef idx="1">
+          <a:effectRef idx="2">
             <a:schemeClr val="accent1"/>
           </a:effectRef>
           <a:fontRef idx="minor">
-            <a:schemeClr val="tx1"/>
+            <a:schemeClr val="lt1"/>
           </a:fontRef>
         </p:style>
-      </p:cxnSp>
+        <p:txBody>
+          <a:bodyPr rtlCol="0" anchor="ctr"/>
+          <a:lstStyle/>
+          <a:p>
+            <a:pPr algn="ctr"/>
+          </a:p>
+        </p:txBody>
+      </p:sp>
       <p:sp>
         <p:nvSpPr>
           <p:cNvPr id="30" name="Rounded Rectangle 29"/>

</xml_diff>